<commit_message>
FHIR-54564 Fixed typo in Micro image
</commit_message>
<xml_diff>
--- a/images/source/parent-child-structure-1.source.pptx
+++ b/images/source/parent-child-structure-1.source.pptx
@@ -430,7 +430,7 @@
           <a:p>
             <a:fld id="{BB2FC3BC-2E5E-4005-81BA-B6AAA29B0B48}" type="datetimeFigureOut">
               <a:rPr lang="en-US" smtClean="0"/>
-              <a:t>1/24/2025</a:t>
+              <a:t>5/11/2026</a:t>
             </a:fld>
             <a:endParaRPr lang="en-US"/>
           </a:p>
@@ -598,7 +598,7 @@
           <a:p>
             <a:fld id="{BB2FC3BC-2E5E-4005-81BA-B6AAA29B0B48}" type="datetimeFigureOut">
               <a:rPr lang="en-US" smtClean="0"/>
-              <a:t>1/24/2025</a:t>
+              <a:t>5/11/2026</a:t>
             </a:fld>
             <a:endParaRPr lang="en-US"/>
           </a:p>
@@ -776,7 +776,7 @@
           <a:p>
             <a:fld id="{BB2FC3BC-2E5E-4005-81BA-B6AAA29B0B48}" type="datetimeFigureOut">
               <a:rPr lang="en-US" smtClean="0"/>
-              <a:t>1/24/2025</a:t>
+              <a:t>5/11/2026</a:t>
             </a:fld>
             <a:endParaRPr lang="en-US"/>
           </a:p>
@@ -944,7 +944,7 @@
           <a:p>
             <a:fld id="{BB2FC3BC-2E5E-4005-81BA-B6AAA29B0B48}" type="datetimeFigureOut">
               <a:rPr lang="en-US" smtClean="0"/>
-              <a:t>1/24/2025</a:t>
+              <a:t>5/11/2026</a:t>
             </a:fld>
             <a:endParaRPr lang="en-US"/>
           </a:p>
@@ -1189,7 +1189,7 @@
           <a:p>
             <a:fld id="{BB2FC3BC-2E5E-4005-81BA-B6AAA29B0B48}" type="datetimeFigureOut">
               <a:rPr lang="en-US" smtClean="0"/>
-              <a:t>1/24/2025</a:t>
+              <a:t>5/11/2026</a:t>
             </a:fld>
             <a:endParaRPr lang="en-US"/>
           </a:p>
@@ -1418,7 +1418,7 @@
           <a:p>
             <a:fld id="{BB2FC3BC-2E5E-4005-81BA-B6AAA29B0B48}" type="datetimeFigureOut">
               <a:rPr lang="en-US" smtClean="0"/>
-              <a:t>1/24/2025</a:t>
+              <a:t>5/11/2026</a:t>
             </a:fld>
             <a:endParaRPr lang="en-US"/>
           </a:p>
@@ -1782,7 +1782,7 @@
           <a:p>
             <a:fld id="{BB2FC3BC-2E5E-4005-81BA-B6AAA29B0B48}" type="datetimeFigureOut">
               <a:rPr lang="en-US" smtClean="0"/>
-              <a:t>1/24/2025</a:t>
+              <a:t>5/11/2026</a:t>
             </a:fld>
             <a:endParaRPr lang="en-US"/>
           </a:p>
@@ -1899,7 +1899,7 @@
           <a:p>
             <a:fld id="{BB2FC3BC-2E5E-4005-81BA-B6AAA29B0B48}" type="datetimeFigureOut">
               <a:rPr lang="en-US" smtClean="0"/>
-              <a:t>1/24/2025</a:t>
+              <a:t>5/11/2026</a:t>
             </a:fld>
             <a:endParaRPr lang="en-US"/>
           </a:p>
@@ -1994,7 +1994,7 @@
           <a:p>
             <a:fld id="{BB2FC3BC-2E5E-4005-81BA-B6AAA29B0B48}" type="datetimeFigureOut">
               <a:rPr lang="en-US" smtClean="0"/>
-              <a:t>1/24/2025</a:t>
+              <a:t>5/11/2026</a:t>
             </a:fld>
             <a:endParaRPr lang="en-US"/>
           </a:p>
@@ -2269,7 +2269,7 @@
           <a:p>
             <a:fld id="{BB2FC3BC-2E5E-4005-81BA-B6AAA29B0B48}" type="datetimeFigureOut">
               <a:rPr lang="en-US" smtClean="0"/>
-              <a:t>1/24/2025</a:t>
+              <a:t>5/11/2026</a:t>
             </a:fld>
             <a:endParaRPr lang="en-US"/>
           </a:p>
@@ -2521,7 +2521,7 @@
           <a:p>
             <a:fld id="{BB2FC3BC-2E5E-4005-81BA-B6AAA29B0B48}" type="datetimeFigureOut">
               <a:rPr lang="en-US" smtClean="0"/>
-              <a:t>1/24/2025</a:t>
+              <a:t>5/11/2026</a:t>
             </a:fld>
             <a:endParaRPr lang="en-US"/>
           </a:p>
@@ -2732,7 +2732,7 @@
           <a:p>
             <a:fld id="{BB2FC3BC-2E5E-4005-81BA-B6AAA29B0B48}" type="datetimeFigureOut">
               <a:rPr lang="en-US" smtClean="0"/>
-              <a:t>1/24/2025</a:t>
+              <a:t>5/11/2026</a:t>
             </a:fld>
             <a:endParaRPr lang="en-US"/>
           </a:p>
@@ -3544,15 +3544,7 @@
             <a:pPr algn="ctr"/>
             <a:r>
               <a:rPr lang="en-US" sz="1400" dirty="0"/>
-              <a:t>(</a:t>
-            </a:r>
-            <a:r>
-              <a:rPr lang="en-US" sz="1400" dirty="0" err="1"/>
-              <a:t>Aenarobic</a:t>
-            </a:r>
-            <a:r>
-              <a:rPr lang="en-US" sz="1400" dirty="0"/>
-              <a:t> Culture)</a:t>
+              <a:t>(Anaerobic Culture)</a:t>
             </a:r>
           </a:p>
         </p:txBody>
@@ -4824,18 +4816,18 @@
 </file>
 
 <file path=customXml/item2.xml><?xml version="1.0" encoding="utf-8"?>
-<p:properties xmlns:p="http://schemas.microsoft.com/office/2006/metadata/properties" xmlns:xsi="http://www.w3.org/2001/XMLSchema-instance" xmlns:pc="http://schemas.microsoft.com/office/infopath/2007/PartnerControls">
-  <documentManagement/>
-</p:properties>
-</file>
-
-<file path=customXml/item3.xml><?xml version="1.0" encoding="utf-8"?>
 <?mso-contentType ?>
 <FormTemplates xmlns="http://schemas.microsoft.com/sharepoint/v3/contenttype/forms">
   <Display>DocumentLibraryForm</Display>
   <Edit>DocumentLibraryForm</Edit>
   <New>DocumentLibraryForm</New>
 </FormTemplates>
+</file>
+
+<file path=customXml/item3.xml><?xml version="1.0" encoding="utf-8"?>
+<p:properties xmlns:p="http://schemas.microsoft.com/office/2006/metadata/properties" xmlns:xsi="http://www.w3.org/2001/XMLSchema-instance" xmlns:pc="http://schemas.microsoft.com/office/infopath/2007/PartnerControls">
+  <documentManagement/>
+</p:properties>
 </file>
 
 <file path=customXml/itemProps1.xml><?xml version="1.0" encoding="utf-8"?>
@@ -4857,6 +4849,14 @@
 </file>
 
 <file path=customXml/itemProps2.xml><?xml version="1.0" encoding="utf-8"?>
+<ds:datastoreItem xmlns:ds="http://schemas.openxmlformats.org/officeDocument/2006/customXml" ds:itemID="{F808E56A-0D1D-4B43-BD05-FF4B6D63C094}">
+  <ds:schemaRefs>
+    <ds:schemaRef ds:uri="http://schemas.microsoft.com/sharepoint/v3/contenttype/forms"/>
+  </ds:schemaRefs>
+</ds:datastoreItem>
+</file>
+
+<file path=customXml/itemProps3.xml><?xml version="1.0" encoding="utf-8"?>
 <ds:datastoreItem xmlns:ds="http://schemas.openxmlformats.org/officeDocument/2006/customXml" ds:itemID="{4F24EE5C-5772-4CF7-AF7C-C3539B99C359}">
   <ds:schemaRefs>
     <ds:schemaRef ds:uri="http://www.w3.org/XML/1998/namespace"/>
@@ -4872,14 +4872,6 @@
 </ds:datastoreItem>
 </file>
 
-<file path=customXml/itemProps3.xml><?xml version="1.0" encoding="utf-8"?>
-<ds:datastoreItem xmlns:ds="http://schemas.openxmlformats.org/officeDocument/2006/customXml" ds:itemID="{F808E56A-0D1D-4B43-BD05-FF4B6D63C094}">
-  <ds:schemaRefs>
-    <ds:schemaRef ds:uri="http://schemas.microsoft.com/sharepoint/v3/contenttype/forms"/>
-  </ds:schemaRefs>
-</ds:datastoreItem>
-</file>
-
 <file path=docMetadata/LabelInfo.xml><?xml version="1.0" encoding="utf-8"?>
 <clbl:labelList xmlns:clbl="http://schemas.microsoft.com/office/2020/mipLabelMetadata">
   <clbl:label id="{b1851626-05c4-426e-b768-1c35733f6fea}" enabled="1" method="Standard" siteId="{fbc493a8-0d24-4454-a815-f4ca58e8c09d}" removed="0"/>

</xml_diff>